<commit_message>
Regenerate the docs' pictures for the new fit height and insets
Rendered with PowerPoint: `fit` objects are sized with PowerPoint's
1.2-times-the-size line pitch (#10) and `vmargin` above and below
(#15), so they come out a little taller, and a multi-line one now holds
all its lines. The examples' .pptx files are written again too.
</commit_message>
<xml_diff>
--- a/docs/examples/pipeline.pptx
+++ b/docs/examples/pipeline.pptx
@@ -7,7 +7,7 @@
   <p:sldIdLst>
     <p:sldId id="256" r:id="rId7"/>
   </p:sldIdLst>
-  <p:sldSz cx="2827411" cy="1327785" type="screen4x3"/>
+  <p:sldSz cx="2827411" cy="1417320" type="screen4x3"/>
   <p:notesSz cx="6858000" cy="9144000"/>
   <p:defaultTextStyle>
     <a:defPPr>
@@ -3096,7 +3096,7 @@
         </p:nvCxnSpPr>
         <p:spPr>
           <a:xfrm>
-            <a:off x="137160" y="320516"/>
+            <a:off x="137160" y="342900"/>
             <a:ext cx="914400" cy="0"/>
           </a:xfrm>
           <a:prstGeom prst="line">
@@ -3134,8 +3134,8 @@
         </p:nvSpPr>
         <p:spPr>
           <a:xfrm>
-            <a:off x="301056" y="137160"/>
-            <a:ext cx="586606" cy="153352"/>
+            <a:off x="301056" y="156209"/>
+            <a:ext cx="586606" cy="160020"/>
           </a:xfrm>
           <a:prstGeom prst="rect">
             <a:avLst/>
@@ -3148,7 +3148,11 @@
           </a:bodyPr>
           <a:lstStyle/>
           <a:p>
-            <a:pPr algn="ctr"/>
+            <a:pPr algn="ctr">
+              <a:lnSpc>
+                <a:spcPct val="100000"/>
+              </a:lnSpc>
+            </a:pPr>
             <a:r>
               <a:rPr b="0" i="0" sz="1050">
                 <a:solidFill>
@@ -3170,8 +3174,8 @@
         </p:nvSpPr>
         <p:spPr>
           <a:xfrm>
-            <a:off x="301056" y="350520"/>
-            <a:ext cx="586606" cy="153352"/>
+            <a:off x="301056" y="369570"/>
+            <a:ext cx="586606" cy="160020"/>
           </a:xfrm>
           <a:prstGeom prst="rect">
             <a:avLst/>
@@ -3184,7 +3188,11 @@
           </a:bodyPr>
           <a:lstStyle/>
           <a:p>
-            <a:pPr algn="ctr"/>
+            <a:pPr algn="ctr">
+              <a:lnSpc>
+                <a:spcPct val="100000"/>
+              </a:lnSpc>
+            </a:pPr>
             <a:r>
               <a:rPr b="0" i="0" sz="1050">
                 <a:solidFill>
@@ -3207,11 +3215,11 @@
         <p:spPr>
           <a:xfrm>
             <a:off x="1051560" y="137160"/>
-            <a:ext cx="724291" cy="366712"/>
+            <a:ext cx="724291" cy="411479"/>
           </a:xfrm>
           <a:prstGeom prst="roundRect">
             <a:avLst>
-              <a:gd name="adj" fmla="val 25974"/>
+              <a:gd name="adj" fmla="val 23148"/>
             </a:avLst>
           </a:prstGeom>
           <a:noFill/>
@@ -3237,10 +3245,14 @@
           </a:fontRef>
         </p:style>
         <p:txBody>
-          <a:bodyPr rtlCol="0" anchor="ctr" wrap="none" tIns="0" bIns="0"/>
-          <a:lstStyle/>
-          <a:p>
-            <a:pPr algn="ctr"/>
+          <a:bodyPr rtlCol="0" anchor="ctr" wrap="none"/>
+          <a:lstStyle/>
+          <a:p>
+            <a:pPr algn="ctr">
+              <a:lnSpc>
+                <a:spcPct val="100000"/>
+              </a:lnSpc>
+            </a:pPr>
             <a:r>
               <a:rPr b="0" i="0" sz="1050">
                 <a:solidFill>
@@ -3253,7 +3265,11 @@
             </a:r>
           </a:p>
           <a:p>
-            <a:pPr algn="ctr"/>
+            <a:pPr algn="ctr">
+              <a:lnSpc>
+                <a:spcPct val="100000"/>
+              </a:lnSpc>
+            </a:pPr>
             <a:r>
               <a:rPr b="0" i="0" sz="1050">
                 <a:solidFill>
@@ -3275,7 +3291,7 @@
         </p:nvCxnSpPr>
         <p:spPr>
           <a:xfrm>
-            <a:off x="1775851" y="320516"/>
+            <a:off x="1775851" y="342900"/>
             <a:ext cx="914400" cy="0"/>
           </a:xfrm>
           <a:prstGeom prst="line">
@@ -3313,8 +3329,8 @@
         </p:nvSpPr>
         <p:spPr>
           <a:xfrm>
-            <a:off x="2039116" y="137160"/>
-            <a:ext cx="387870" cy="153352"/>
+            <a:off x="2039116" y="156209"/>
+            <a:ext cx="387870" cy="160020"/>
           </a:xfrm>
           <a:prstGeom prst="rect">
             <a:avLst/>
@@ -3327,7 +3343,11 @@
           </a:bodyPr>
           <a:lstStyle/>
           <a:p>
-            <a:pPr algn="ctr"/>
+            <a:pPr algn="ctr">
+              <a:lnSpc>
+                <a:spcPct val="100000"/>
+              </a:lnSpc>
+            </a:pPr>
             <a:r>
               <a:rPr b="0" i="0" sz="1050">
                 <a:solidFill>
@@ -3349,8 +3369,8 @@
         </p:nvSpPr>
         <p:spPr>
           <a:xfrm>
-            <a:off x="2039116" y="350520"/>
-            <a:ext cx="387870" cy="153352"/>
+            <a:off x="2039116" y="369570"/>
+            <a:ext cx="387870" cy="160020"/>
           </a:xfrm>
           <a:prstGeom prst="rect">
             <a:avLst/>
@@ -3363,7 +3383,11 @@
           </a:bodyPr>
           <a:lstStyle/>
           <a:p>
-            <a:pPr algn="ctr"/>
+            <a:pPr algn="ctr">
+              <a:lnSpc>
+                <a:spcPct val="100000"/>
+              </a:lnSpc>
+            </a:pPr>
             <a:r>
               <a:rPr b="0" i="0" sz="1050">
                 <a:solidFill>
@@ -3385,7 +3409,7 @@
         </p:nvCxnSpPr>
         <p:spPr>
           <a:xfrm>
-            <a:off x="1413705" y="503872"/>
+            <a:off x="1413705" y="548640"/>
             <a:ext cx="0" cy="320040"/>
           </a:xfrm>
           <a:prstGeom prst="line">
@@ -3423,8 +3447,8 @@
         </p:nvSpPr>
         <p:spPr>
           <a:xfrm>
-            <a:off x="1064892" y="823912"/>
-            <a:ext cx="697626" cy="366712"/>
+            <a:off x="1064892" y="868680"/>
+            <a:ext cx="697626" cy="411479"/>
           </a:xfrm>
           <a:prstGeom prst="foldedCorner">
             <a:avLst/>
@@ -3452,10 +3476,14 @@
           </a:fontRef>
         </p:style>
         <p:txBody>
-          <a:bodyPr rtlCol="0" anchor="ctr" wrap="none" tIns="0" bIns="0"/>
-          <a:lstStyle/>
-          <a:p>
-            <a:pPr algn="ctr"/>
+          <a:bodyPr rtlCol="0" anchor="ctr" wrap="none"/>
+          <a:lstStyle/>
+          <a:p>
+            <a:pPr algn="ctr">
+              <a:lnSpc>
+                <a:spcPct val="100000"/>
+              </a:lnSpc>
+            </a:pPr>
             <a:r>
               <a:rPr b="0" i="0" sz="1050">
                 <a:solidFill>
@@ -3468,7 +3496,11 @@
             </a:r>
           </a:p>
           <a:p>
-            <a:pPr algn="ctr"/>
+            <a:pPr algn="ctr">
+              <a:lnSpc>
+                <a:spcPct val="100000"/>
+              </a:lnSpc>
+            </a:pPr>
             <a:r>
               <a:rPr b="0" i="0" sz="1050">
                 <a:solidFill>

</xml_diff>

<commit_message>
Draw the README's loop through you, not through the LLM's own checks
The picture had the LLM look at the .png and fix its .pik by itself,
and you look at the .png too. That self-check is the harness's, not
pikslide's, and it hid what pikslide adds: a .pptx you can edit.

Now the .png is only an output. The loop runs through you: you prompt
the LLM, edit the .pik, or edit the .pptx in PowerPoint, and the prompt
arrow gives two examples, a first request and "apply my edits in the
.pptx to the .pik". The README's steps say the same, and why the LLM
can carry the edits over: each shape is named after its label in the
.pik.
</commit_message>
<xml_diff>
--- a/docs/examples/pipeline.pptx
+++ b/docs/examples/pipeline.pptx
@@ -7,7 +7,7 @@
   <p:sldIdLst>
     <p:sldId id="256" r:id="rId7"/>
   </p:sldIdLst>
-  <p:sldSz cx="6266914" cy="3263265" type="screen4x3"/>
+  <p:sldSz cx="6492240" cy="2651760" type="screen4x3"/>
   <p:notesSz cx="6858000" cy="9144000"/>
   <p:defaultTextStyle>
     <a:defPPr>
@@ -3096,7 +3096,7 @@
         </p:nvSpPr>
         <p:spPr>
           <a:xfrm>
-            <a:off x="137160" y="1205865"/>
+            <a:off x="137160" y="594360"/>
             <a:ext cx="1097280" cy="502920"/>
           </a:xfrm>
           <a:prstGeom prst="rect">
@@ -3154,7 +3154,103 @@
         </p:nvCxnSpPr>
         <p:spPr>
           <a:xfrm>
-            <a:off x="1234440" y="1457325"/>
+            <a:off x="1234440" y="845820"/>
+            <a:ext cx="1371600" cy="0"/>
+          </a:xfrm>
+          <a:prstGeom prst="line">
+            <a:avLst/>
+          </a:prstGeom>
+          <a:ln w="13716">
+            <a:solidFill>
+              <a:srgbClr val="000000"/>
+            </a:solidFill>
+            <a:headEnd type="none"/>
+            <a:tailEnd type="triangle"/>
+          </a:ln>
+          <a:effectLst/>
+        </p:spPr>
+        <p:style>
+          <a:lnRef idx="2">
+            <a:schemeClr val="accent1"/>
+          </a:lnRef>
+          <a:fillRef idx="0">
+            <a:schemeClr val="accent1"/>
+          </a:fillRef>
+          <a:effectRef idx="1">
+            <a:schemeClr val="accent1"/>
+          </a:effectRef>
+          <a:fontRef idx="minor">
+            <a:schemeClr val="tx1"/>
+          </a:fontRef>
+        </p:style>
+      </p:cxnSp>
+      <p:sp>
+        <p:nvSpPr>
+          <p:cNvPr id="4" name="Pik"/>
+          <p:cNvSpPr/>
+          <p:nvPr/>
+        </p:nvSpPr>
+        <p:spPr>
+          <a:xfrm>
+            <a:off x="2606040" y="594360"/>
+            <a:ext cx="731519" cy="502920"/>
+          </a:xfrm>
+          <a:prstGeom prst="foldedCorner">
+            <a:avLst/>
+          </a:prstGeom>
+          <a:noFill/>
+          <a:ln w="13716">
+            <a:solidFill>
+              <a:srgbClr val="000000"/>
+            </a:solidFill>
+          </a:ln>
+          <a:effectLst/>
+        </p:spPr>
+        <p:style>
+          <a:lnRef idx="1">
+            <a:schemeClr val="accent1"/>
+          </a:lnRef>
+          <a:fillRef idx="3">
+            <a:schemeClr val="accent1"/>
+          </a:fillRef>
+          <a:effectRef idx="2">
+            <a:schemeClr val="accent1"/>
+          </a:effectRef>
+          <a:fontRef idx="minor">
+            <a:schemeClr val="lt1"/>
+          </a:fontRef>
+        </p:style>
+        <p:txBody>
+          <a:bodyPr rtlCol="0" anchor="ctr" wrap="square"/>
+          <a:lstStyle/>
+          <a:p>
+            <a:pPr algn="ctr">
+              <a:lnSpc>
+                <a:spcPct val="100000"/>
+              </a:lnSpc>
+            </a:pPr>
+            <a:r>
+              <a:rPr b="0" i="0" sz="1050">
+                <a:solidFill>
+                  <a:srgbClr val="000000"/>
+                </a:solidFill>
+                <a:latin typeface="+mn-lt"/>
+                <a:ea typeface="+mn-ea"/>
+              </a:rPr>
+              <a:t>.pik</a:t>
+            </a:r>
+          </a:p>
+        </p:txBody>
+      </p:sp>
+      <p:cxnSp>
+        <p:nvCxnSpPr>
+          <p:cNvPr id="5" name="arrow 2"/>
+          <p:cNvCxnSpPr/>
+          <p:nvPr/>
+        </p:nvCxnSpPr>
+        <p:spPr>
+          <a:xfrm>
+            <a:off x="3337560" y="845820"/>
             <a:ext cx="457200" cy="0"/>
           </a:xfrm>
           <a:prstGeom prst="line">
@@ -3186,110 +3282,14 @@
       </p:cxnSp>
       <p:sp>
         <p:nvSpPr>
-          <p:cNvPr id="4" name="Pik"/>
-          <p:cNvSpPr/>
-          <p:nvPr/>
-        </p:nvSpPr>
-        <p:spPr>
-          <a:xfrm>
-            <a:off x="1691640" y="1205865"/>
-            <a:ext cx="731519" cy="502920"/>
-          </a:xfrm>
-          <a:prstGeom prst="foldedCorner">
-            <a:avLst/>
-          </a:prstGeom>
-          <a:noFill/>
-          <a:ln w="13716">
-            <a:solidFill>
-              <a:srgbClr val="000000"/>
-            </a:solidFill>
-          </a:ln>
-          <a:effectLst/>
-        </p:spPr>
-        <p:style>
-          <a:lnRef idx="1">
-            <a:schemeClr val="accent1"/>
-          </a:lnRef>
-          <a:fillRef idx="3">
-            <a:schemeClr val="accent1"/>
-          </a:fillRef>
-          <a:effectRef idx="2">
-            <a:schemeClr val="accent1"/>
-          </a:effectRef>
-          <a:fontRef idx="minor">
-            <a:schemeClr val="lt1"/>
-          </a:fontRef>
-        </p:style>
-        <p:txBody>
-          <a:bodyPr rtlCol="0" anchor="ctr" wrap="square"/>
-          <a:lstStyle/>
-          <a:p>
-            <a:pPr algn="ctr">
-              <a:lnSpc>
-                <a:spcPct val="100000"/>
-              </a:lnSpc>
-            </a:pPr>
-            <a:r>
-              <a:rPr b="0" i="0" sz="1050">
-                <a:solidFill>
-                  <a:srgbClr val="000000"/>
-                </a:solidFill>
-                <a:latin typeface="+mn-lt"/>
-                <a:ea typeface="+mn-ea"/>
-              </a:rPr>
-              <a:t>.pik</a:t>
-            </a:r>
-          </a:p>
-        </p:txBody>
-      </p:sp>
-      <p:cxnSp>
-        <p:nvCxnSpPr>
-          <p:cNvPr id="5" name="arrow 2"/>
-          <p:cNvCxnSpPr/>
-          <p:nvPr/>
-        </p:nvCxnSpPr>
-        <p:spPr>
-          <a:xfrm>
-            <a:off x="2423160" y="1457325"/>
-            <a:ext cx="457200" cy="0"/>
-          </a:xfrm>
-          <a:prstGeom prst="line">
-            <a:avLst/>
-          </a:prstGeom>
-          <a:ln w="13716">
-            <a:solidFill>
-              <a:srgbClr val="000000"/>
-            </a:solidFill>
-            <a:headEnd type="none"/>
-            <a:tailEnd type="triangle"/>
-          </a:ln>
-          <a:effectLst/>
-        </p:spPr>
-        <p:style>
-          <a:lnRef idx="2">
-            <a:schemeClr val="accent1"/>
-          </a:lnRef>
-          <a:fillRef idx="0">
-            <a:schemeClr val="accent1"/>
-          </a:fillRef>
-          <a:effectRef idx="1">
-            <a:schemeClr val="accent1"/>
-          </a:effectRef>
-          <a:fontRef idx="minor">
-            <a:schemeClr val="tx1"/>
-          </a:fontRef>
-        </p:style>
-      </p:cxnSp>
-      <p:sp>
-        <p:nvSpPr>
           <p:cNvPr id="6" name="Pikslide"/>
           <p:cNvSpPr/>
           <p:nvPr/>
         </p:nvSpPr>
         <p:spPr>
           <a:xfrm>
-            <a:off x="2880360" y="1205865"/>
-            <a:ext cx="1097280" cy="502920"/>
+            <a:off x="3794760" y="594360"/>
+            <a:ext cx="1097279" cy="502920"/>
           </a:xfrm>
           <a:prstGeom prst="rect">
             <a:avLst/>
@@ -3351,7 +3351,7 @@
         </p:nvSpPr>
         <p:spPr>
           <a:xfrm>
-            <a:off x="4709160" y="748665"/>
+            <a:off x="5623560" y="137160"/>
             <a:ext cx="731520" cy="502920"/>
           </a:xfrm>
           <a:prstGeom prst="foldedCorner">
@@ -3409,7 +3409,7 @@
         </p:nvSpPr>
         <p:spPr>
           <a:xfrm>
-            <a:off x="4709160" y="1663065"/>
+            <a:off x="5623560" y="1051560"/>
             <a:ext cx="731520" cy="502920"/>
           </a:xfrm>
           <a:prstGeom prst="foldedCorner">
@@ -3467,7 +3467,7 @@
         </p:nvSpPr>
         <p:spPr>
           <a:xfrm>
-            <a:off x="3977640" y="1000125"/>
+            <a:off x="4892040" y="388620"/>
             <a:ext cx="731520" cy="457200"/>
           </a:xfrm>
           <a:custGeom>
@@ -3533,7 +3533,7 @@
         </p:nvSpPr>
         <p:spPr>
           <a:xfrm>
-            <a:off x="4312887" y="777240"/>
+            <a:off x="5227287" y="165735"/>
             <a:ext cx="426784" cy="445770"/>
           </a:xfrm>
           <a:prstGeom prst="rect">
@@ -3589,8 +3589,8 @@
         </p:nvSpPr>
         <p:spPr>
           <a:xfrm>
-            <a:off x="3977640" y="1457325"/>
-            <a:ext cx="731520" cy="457200"/>
+            <a:off x="4892040" y="845820"/>
+            <a:ext cx="731520" cy="457199"/>
           </a:xfrm>
           <a:custGeom>
             <a:avLst/>
@@ -3599,7 +3599,7 @@
             <a:cxnLst/>
             <a:rect l="l" t="t" r="r" b="b"/>
             <a:pathLst>
-              <a:path w="731520" h="457200">
+              <a:path w="731520" h="457199">
                 <a:moveTo>
                   <a:pt x="0" y="0"/>
                 </a:moveTo>
@@ -3607,10 +3607,10 @@
                   <a:pt x="365760" y="0"/>
                 </a:lnTo>
                 <a:lnTo>
-                  <a:pt x="365760" y="457200"/>
+                  <a:pt x="365760" y="457199"/>
                 </a:lnTo>
                 <a:lnTo>
-                  <a:pt x="731520" y="457200"/>
+                  <a:pt x="731520" y="457199"/>
                 </a:lnTo>
               </a:path>
             </a:pathLst>
@@ -3655,8 +3655,8 @@
         </p:nvSpPr>
         <p:spPr>
           <a:xfrm>
-            <a:off x="137160" y="2714625"/>
-            <a:ext cx="5852160" cy="411480"/>
+            <a:off x="137160" y="2103120"/>
+            <a:ext cx="6217919" cy="411480"/>
           </a:xfrm>
           <a:prstGeom prst="rect">
             <a:avLst/>
@@ -3717,7 +3717,7 @@
         </p:nvCxnSpPr>
         <p:spPr>
           <a:xfrm flipV="1">
-            <a:off x="685800" y="1708785"/>
+            <a:off x="685800" y="1097280"/>
             <a:ext cx="0" cy="1005840"/>
           </a:xfrm>
           <a:prstGeom prst="line">
@@ -3755,8 +3755,8 @@
         </p:nvSpPr>
         <p:spPr>
           <a:xfrm>
-            <a:off x="777240" y="2131695"/>
-            <a:ext cx="405407" cy="160020"/>
+            <a:off x="777240" y="1413509"/>
+            <a:ext cx="1943149" cy="160020"/>
           </a:xfrm>
           <a:prstGeom prst="rect">
             <a:avLst/>
@@ -3787,15 +3787,95 @@
           </a:p>
         </p:txBody>
       </p:sp>
+      <p:sp>
+        <p:nvSpPr>
+          <p:cNvPr id="15" name="arrow 5 text 2"/>
+          <p:cNvSpPr txBox="1"/>
+          <p:nvPr/>
+        </p:nvSpPr>
+        <p:spPr>
+          <a:xfrm>
+            <a:off x="777240" y="1520189"/>
+            <a:ext cx="1943149" cy="160020"/>
+          </a:xfrm>
+          <a:prstGeom prst="rect">
+            <a:avLst/>
+          </a:prstGeom>
+          <a:noFill/>
+        </p:spPr>
+        <p:txBody>
+          <a:bodyPr wrap="none" lIns="0" rIns="0" tIns="0" bIns="0">
+            <a:spAutoFit/>
+          </a:bodyPr>
+          <a:lstStyle/>
+          <a:p>
+            <a:pPr algn="l">
+              <a:lnSpc>
+                <a:spcPct val="100000"/>
+              </a:lnSpc>
+            </a:pPr>
+            <a:r>
+              <a:rPr b="0" i="0" sz="900">
+                <a:solidFill>
+                  <a:srgbClr val="000000"/>
+                </a:solidFill>
+                <a:latin typeface="+mn-lt"/>
+                <a:ea typeface="+mn-ea"/>
+              </a:rPr>
+              <a:t>e.g. “draw how Japan's capital moved”</a:t>
+            </a:r>
+          </a:p>
+        </p:txBody>
+      </p:sp>
+      <p:sp>
+        <p:nvSpPr>
+          <p:cNvPr id="16" name="arrow 5 text 3"/>
+          <p:cNvSpPr txBox="1"/>
+          <p:nvPr/>
+        </p:nvSpPr>
+        <p:spPr>
+          <a:xfrm>
+            <a:off x="777240" y="1626870"/>
+            <a:ext cx="1943149" cy="160019"/>
+          </a:xfrm>
+          <a:prstGeom prst="rect">
+            <a:avLst/>
+          </a:prstGeom>
+          <a:noFill/>
+        </p:spPr>
+        <p:txBody>
+          <a:bodyPr wrap="none" lIns="0" rIns="0" tIns="0" bIns="0">
+            <a:spAutoFit/>
+          </a:bodyPr>
+          <a:lstStyle/>
+          <a:p>
+            <a:pPr algn="l">
+              <a:lnSpc>
+                <a:spcPct val="100000"/>
+              </a:lnSpc>
+            </a:pPr>
+            <a:r>
+              <a:rPr b="0" i="0" sz="900">
+                <a:solidFill>
+                  <a:srgbClr val="000000"/>
+                </a:solidFill>
+                <a:latin typeface="+mn-lt"/>
+                <a:ea typeface="+mn-ea"/>
+              </a:rPr>
+              <a:t>or “apply my edits in the .pptx to the .pik”</a:t>
+            </a:r>
+          </a:p>
+        </p:txBody>
+      </p:sp>
       <p:cxnSp>
         <p:nvCxnSpPr>
-          <p:cNvPr id="15" name="arrow 6"/>
+          <p:cNvPr id="17" name="arrow 6"/>
           <p:cNvCxnSpPr/>
           <p:nvPr/>
         </p:nvCxnSpPr>
         <p:spPr>
           <a:xfrm flipV="1">
-            <a:off x="2057400" y="1708785"/>
+            <a:off x="2971800" y="1097280"/>
             <a:ext cx="0" cy="1005840"/>
           </a:xfrm>
           <a:prstGeom prst="line">
@@ -3827,14 +3907,14 @@
       </p:cxnSp>
       <p:sp>
         <p:nvSpPr>
-          <p:cNvPr id="16" name="arrow 6 text 1"/>
+          <p:cNvPr id="18" name="arrow 6 text 1"/>
           <p:cNvSpPr txBox="1"/>
           <p:nvPr/>
         </p:nvSpPr>
         <p:spPr>
           <a:xfrm>
-            <a:off x="2148840" y="2131695"/>
-            <a:ext cx="274320" cy="160020"/>
+            <a:off x="3063240" y="1520189"/>
+            <a:ext cx="274319" cy="160020"/>
           </a:xfrm>
           <a:prstGeom prst="rect">
             <a:avLst/>
@@ -3867,13 +3947,13 @@
       </p:sp>
       <p:cxnSp>
         <p:nvCxnSpPr>
-          <p:cNvPr id="17" name="arrow 7"/>
+          <p:cNvPr id="19" name="arrow 7"/>
           <p:cNvCxnSpPr/>
           <p:nvPr/>
         </p:nvCxnSpPr>
         <p:spPr>
           <a:xfrm flipV="1">
-            <a:off x="5074920" y="2165985"/>
+            <a:off x="5989320" y="1554480"/>
             <a:ext cx="0" cy="548640"/>
           </a:xfrm>
           <a:prstGeom prst="line">
@@ -3905,13 +3985,13 @@
       </p:cxnSp>
       <p:sp>
         <p:nvSpPr>
-          <p:cNvPr id="18" name="arrow 7 text 1"/>
+          <p:cNvPr id="20" name="arrow 7 text 1"/>
           <p:cNvSpPr txBox="1"/>
           <p:nvPr/>
         </p:nvSpPr>
         <p:spPr>
           <a:xfrm>
-            <a:off x="3987174" y="2360295"/>
+            <a:off x="4901574" y="1748789"/>
             <a:ext cx="996305" cy="160019"/>
           </a:xfrm>
           <a:prstGeom prst="rect">
@@ -3939,247 +4019,6 @@
                 <a:ea typeface="+mn-ea"/>
               </a:rPr>
               <a:t>edit in PowerPoint</a:t>
-            </a:r>
-          </a:p>
-        </p:txBody>
-      </p:sp>
-      <p:sp>
-        <p:nvSpPr>
-          <p:cNvPr id="19" name="arrow 8"/>
-          <p:cNvSpPr/>
-          <p:nvPr/>
-        </p:nvSpPr>
-        <p:spPr>
-          <a:xfrm>
-            <a:off x="5440680" y="1000125"/>
-            <a:ext cx="274320" cy="1714500"/>
-          </a:xfrm>
-          <a:custGeom>
-            <a:avLst/>
-            <a:gdLst/>
-            <a:ahLst/>
-            <a:cxnLst/>
-            <a:rect l="l" t="t" r="r" b="b"/>
-            <a:pathLst>
-              <a:path w="274320" h="1714500">
-                <a:moveTo>
-                  <a:pt x="0" y="0"/>
-                </a:moveTo>
-                <a:lnTo>
-                  <a:pt x="274320" y="0"/>
-                </a:lnTo>
-                <a:lnTo>
-                  <a:pt x="274320" y="1714500"/>
-                </a:lnTo>
-              </a:path>
-            </a:pathLst>
-          </a:custGeom>
-          <a:noFill/>
-          <a:ln w="13716">
-            <a:solidFill>
-              <a:srgbClr val="000000"/>
-            </a:solidFill>
-            <a:headEnd type="none"/>
-            <a:tailEnd type="triangle"/>
-          </a:ln>
-          <a:effectLst/>
-        </p:spPr>
-        <p:style>
-          <a:lnRef idx="1">
-            <a:schemeClr val="accent1"/>
-          </a:lnRef>
-          <a:fillRef idx="3">
-            <a:schemeClr val="accent1"/>
-          </a:fillRef>
-          <a:effectRef idx="2">
-            <a:schemeClr val="accent1"/>
-          </a:effectRef>
-          <a:fontRef idx="minor">
-            <a:schemeClr val="lt1"/>
-          </a:fontRef>
-        </p:style>
-        <p:txBody>
-          <a:bodyPr rtlCol="0" anchor="ctr"/>
-          <a:lstStyle/>
-          <a:p>
-            <a:pPr algn="ctr"/>
-          </a:p>
-        </p:txBody>
-      </p:sp>
-      <p:sp>
-        <p:nvSpPr>
-          <p:cNvPr id="20" name="text 2"/>
-          <p:cNvSpPr/>
-          <p:nvPr/>
-        </p:nvSpPr>
-        <p:spPr>
-          <a:xfrm>
-            <a:off x="5715000" y="1788795"/>
-            <a:ext cx="414754" cy="251459"/>
-          </a:xfrm>
-          <a:prstGeom prst="rect">
-            <a:avLst/>
-          </a:prstGeom>
-          <a:noFill/>
-          <a:ln>
-            <a:noFill/>
-          </a:ln>
-          <a:effectLst/>
-        </p:spPr>
-        <p:style>
-          <a:lnRef idx="1">
-            <a:schemeClr val="accent1"/>
-          </a:lnRef>
-          <a:fillRef idx="3">
-            <a:schemeClr val="accent1"/>
-          </a:fillRef>
-          <a:effectRef idx="2">
-            <a:schemeClr val="accent1"/>
-          </a:effectRef>
-          <a:fontRef idx="minor">
-            <a:schemeClr val="lt1"/>
-          </a:fontRef>
-        </p:style>
-        <p:txBody>
-          <a:bodyPr rtlCol="0" anchor="ctr" wrap="none"/>
-          <a:lstStyle/>
-          <a:p>
-            <a:pPr algn="l">
-              <a:lnSpc>
-                <a:spcPct val="100000"/>
-              </a:lnSpc>
-            </a:pPr>
-            <a:r>
-              <a:rPr b="0" i="0" sz="1050">
-                <a:solidFill>
-                  <a:srgbClr val="000000"/>
-                </a:solidFill>
-                <a:latin typeface="+mn-lt"/>
-                <a:ea typeface="+mn-ea"/>
-              </a:rPr>
-              <a:t>look</a:t>
-            </a:r>
-          </a:p>
-        </p:txBody>
-      </p:sp>
-      <p:sp>
-        <p:nvSpPr>
-          <p:cNvPr id="21" name="arrow 9"/>
-          <p:cNvSpPr/>
-          <p:nvPr/>
-        </p:nvSpPr>
-        <p:spPr>
-          <a:xfrm>
-            <a:off x="685800" y="382905"/>
-            <a:ext cx="4389120" cy="822960"/>
-          </a:xfrm>
-          <a:custGeom>
-            <a:avLst/>
-            <a:gdLst/>
-            <a:ahLst/>
-            <a:cxnLst/>
-            <a:rect l="l" t="t" r="r" b="b"/>
-            <a:pathLst>
-              <a:path w="4389120" h="822960">
-                <a:moveTo>
-                  <a:pt x="4389120" y="365760"/>
-                </a:moveTo>
-                <a:lnTo>
-                  <a:pt x="4389120" y="0"/>
-                </a:lnTo>
-                <a:lnTo>
-                  <a:pt x="0" y="0"/>
-                </a:lnTo>
-                <a:lnTo>
-                  <a:pt x="0" y="822960"/>
-                </a:lnTo>
-              </a:path>
-            </a:pathLst>
-          </a:custGeom>
-          <a:noFill/>
-          <a:ln w="13716">
-            <a:solidFill>
-              <a:srgbClr val="000000"/>
-            </a:solidFill>
-            <a:headEnd type="none"/>
-            <a:tailEnd type="triangle"/>
-          </a:ln>
-          <a:effectLst/>
-        </p:spPr>
-        <p:style>
-          <a:lnRef idx="1">
-            <a:schemeClr val="accent1"/>
-          </a:lnRef>
-          <a:fillRef idx="3">
-            <a:schemeClr val="accent1"/>
-          </a:fillRef>
-          <a:effectRef idx="2">
-            <a:schemeClr val="accent1"/>
-          </a:effectRef>
-          <a:fontRef idx="minor">
-            <a:schemeClr val="lt1"/>
-          </a:fontRef>
-        </p:style>
-        <p:txBody>
-          <a:bodyPr rtlCol="0" anchor="ctr"/>
-          <a:lstStyle/>
-          <a:p>
-            <a:pPr algn="ctr"/>
-          </a:p>
-        </p:txBody>
-      </p:sp>
-      <p:sp>
-        <p:nvSpPr>
-          <p:cNvPr id="22" name="text 3"/>
-          <p:cNvSpPr/>
-          <p:nvPr/>
-        </p:nvSpPr>
-        <p:spPr>
-          <a:xfrm>
-            <a:off x="2599136" y="137160"/>
-            <a:ext cx="1659726" cy="491490"/>
-          </a:xfrm>
-          <a:prstGeom prst="rect">
-            <a:avLst/>
-          </a:prstGeom>
-          <a:noFill/>
-          <a:ln>
-            <a:noFill/>
-          </a:ln>
-          <a:effectLst/>
-        </p:spPr>
-        <p:style>
-          <a:lnRef idx="1">
-            <a:schemeClr val="accent1"/>
-          </a:lnRef>
-          <a:fillRef idx="3">
-            <a:schemeClr val="accent1"/>
-          </a:fillRef>
-          <a:effectRef idx="2">
-            <a:schemeClr val="accent1"/>
-          </a:effectRef>
-          <a:fontRef idx="minor">
-            <a:schemeClr val="lt1"/>
-          </a:fontRef>
-        </p:style>
-        <p:txBody>
-          <a:bodyPr rtlCol="0" anchor="ctr" wrap="none" bIns="285749"/>
-          <a:lstStyle/>
-          <a:p>
-            <a:pPr algn="ctr">
-              <a:lnSpc>
-                <a:spcPct val="100000"/>
-              </a:lnSpc>
-            </a:pPr>
-            <a:r>
-              <a:rPr b="0" i="0" sz="1050">
-                <a:solidFill>
-                  <a:srgbClr val="000000"/>
-                </a:solidFill>
-                <a:latin typeface="+mn-lt"/>
-                <a:ea typeface="+mn-ea"/>
-              </a:rPr>
-              <a:t>look at the .png, fix the .pik</a:t>
             </a:r>
           </a:p>
         </p:txBody>

</xml_diff>

<commit_message>
Draw the README's picture as a slide, with the LLM as optional
The LLM is optional: you can write the .pik yourself. So the LLM and
its arrows, your prompt and the .pik it writes, are dashed, and the
arrow from you to the .pik is "edit in a text editor", beside "edit in
PowerPoint".

And it's drawn as a slide would be: names in bold, theme fills, the LLM
and pikslide as rounded boxes (pikslide solid, its name in white), the
files as PowerPoint's flowchart document, and what pikslide does, from
the .pik to the files it writes, twice as thick. A preset's edges are
its box's, and a document's wavy bottom is a fifteenth of its height
above that box's at the middle, so the arrows up to a file end there.

The README shows the .pik as it is, and its alt text says the LLM is
optional.
</commit_message>
<xml_diff>
--- a/docs/examples/pipeline.pptx
+++ b/docs/examples/pipeline.pptx
@@ -3099,14 +3099,22 @@
             <a:off x="137160" y="594360"/>
             <a:ext cx="1097280" cy="502920"/>
           </a:xfrm>
-          <a:prstGeom prst="rect">
-            <a:avLst/>
+          <a:prstGeom prst="roundRect">
+            <a:avLst>
+              <a:gd name="adj" fmla="val 18181"/>
+            </a:avLst>
           </a:prstGeom>
-          <a:noFill/>
+          <a:solidFill>
+            <a:schemeClr val="accent1">
+              <a:lumMod val="40000"/>
+              <a:lumOff val="60000"/>
+            </a:schemeClr>
+          </a:solidFill>
           <a:ln w="13716">
             <a:solidFill>
               <a:srgbClr val="000000"/>
             </a:solidFill>
+            <a:prstDash val="dash"/>
           </a:ln>
           <a:effectLst/>
         </p:spPr>
@@ -3134,7 +3142,7 @@
               </a:lnSpc>
             </a:pPr>
             <a:r>
-              <a:rPr b="0" i="0" sz="1050">
+              <a:rPr b="1" i="0" sz="1050">
                 <a:solidFill>
                   <a:srgbClr val="000000"/>
                 </a:solidFill>
@@ -3164,6 +3172,7 @@
             <a:solidFill>
               <a:srgbClr val="000000"/>
             </a:solidFill>
+            <a:prstDash val="dash"/>
             <a:headEnd type="none"/>
             <a:tailEnd type="triangle"/>
           </a:ln>
@@ -3195,107 +3204,11 @@
             <a:off x="2606040" y="594360"/>
             <a:ext cx="731519" cy="502920"/>
           </a:xfrm>
-          <a:prstGeom prst="foldedCorner">
-            <a:avLst/>
-          </a:prstGeom>
-          <a:noFill/>
-          <a:ln w="13716">
-            <a:solidFill>
-              <a:srgbClr val="000000"/>
-            </a:solidFill>
-          </a:ln>
-          <a:effectLst/>
-        </p:spPr>
-        <p:style>
-          <a:lnRef idx="1">
-            <a:schemeClr val="accent1"/>
-          </a:lnRef>
-          <a:fillRef idx="3">
-            <a:schemeClr val="accent1"/>
-          </a:fillRef>
-          <a:effectRef idx="2">
-            <a:schemeClr val="accent1"/>
-          </a:effectRef>
-          <a:fontRef idx="minor">
-            <a:schemeClr val="lt1"/>
-          </a:fontRef>
-        </p:style>
-        <p:txBody>
-          <a:bodyPr rtlCol="0" anchor="ctr" wrap="square"/>
-          <a:lstStyle/>
-          <a:p>
-            <a:pPr algn="ctr">
-              <a:lnSpc>
-                <a:spcPct val="100000"/>
-              </a:lnSpc>
-            </a:pPr>
-            <a:r>
-              <a:rPr b="0" i="0" sz="1050">
-                <a:solidFill>
-                  <a:srgbClr val="000000"/>
-                </a:solidFill>
-                <a:latin typeface="+mn-lt"/>
-                <a:ea typeface="+mn-ea"/>
-              </a:rPr>
-              <a:t>.pik</a:t>
-            </a:r>
-          </a:p>
-        </p:txBody>
-      </p:sp>
-      <p:cxnSp>
-        <p:nvCxnSpPr>
-          <p:cNvPr id="5" name="arrow 2"/>
-          <p:cNvCxnSpPr/>
-          <p:nvPr/>
-        </p:nvCxnSpPr>
-        <p:spPr>
-          <a:xfrm>
-            <a:off x="3337560" y="845820"/>
-            <a:ext cx="457200" cy="0"/>
-          </a:xfrm>
-          <a:prstGeom prst="line">
-            <a:avLst/>
-          </a:prstGeom>
-          <a:ln w="13716">
-            <a:solidFill>
-              <a:srgbClr val="000000"/>
-            </a:solidFill>
-            <a:headEnd type="none"/>
-            <a:tailEnd type="triangle"/>
-          </a:ln>
-          <a:effectLst/>
-        </p:spPr>
-        <p:style>
-          <a:lnRef idx="2">
-            <a:schemeClr val="accent1"/>
-          </a:lnRef>
-          <a:fillRef idx="0">
-            <a:schemeClr val="accent1"/>
-          </a:fillRef>
-          <a:effectRef idx="1">
-            <a:schemeClr val="accent1"/>
-          </a:effectRef>
-          <a:fontRef idx="minor">
-            <a:schemeClr val="tx1"/>
-          </a:fontRef>
-        </p:style>
-      </p:cxnSp>
-      <p:sp>
-        <p:nvSpPr>
-          <p:cNvPr id="6" name="Pikslide"/>
-          <p:cNvSpPr/>
-          <p:nvPr/>
-        </p:nvSpPr>
-        <p:spPr>
-          <a:xfrm>
-            <a:off x="3794760" y="594360"/>
-            <a:ext cx="1097279" cy="502920"/>
-          </a:xfrm>
-          <a:prstGeom prst="rect">
+          <a:prstGeom prst="flowChartDocument">
             <a:avLst/>
           </a:prstGeom>
           <a:solidFill>
-            <a:schemeClr val="accent1">
+            <a:schemeClr val="accent2">
               <a:lumMod val="40000"/>
               <a:lumOff val="60000"/>
             </a:schemeClr>
@@ -3338,26 +3251,68 @@
                 <a:latin typeface="+mn-lt"/>
                 <a:ea typeface="+mn-ea"/>
               </a:rPr>
-              <a:t>pikslide</a:t>
-            </a:r>
-          </a:p>
-        </p:txBody>
-      </p:sp>
-      <p:sp>
-        <p:nvSpPr>
-          <p:cNvPr id="7" name="Png"/>
+              <a:t>.pik</a:t>
+            </a:r>
+          </a:p>
+        </p:txBody>
+      </p:sp>
+      <p:cxnSp>
+        <p:nvCxnSpPr>
+          <p:cNvPr id="5" name="arrow 2"/>
+          <p:cNvCxnSpPr/>
+          <p:nvPr/>
+        </p:nvCxnSpPr>
+        <p:spPr>
+          <a:xfrm>
+            <a:off x="3337560" y="845820"/>
+            <a:ext cx="457200" cy="0"/>
+          </a:xfrm>
+          <a:prstGeom prst="line">
+            <a:avLst/>
+          </a:prstGeom>
+          <a:ln w="27432">
+            <a:solidFill>
+              <a:srgbClr val="000000"/>
+            </a:solidFill>
+            <a:headEnd type="none"/>
+            <a:tailEnd type="triangle"/>
+          </a:ln>
+          <a:effectLst/>
+        </p:spPr>
+        <p:style>
+          <a:lnRef idx="2">
+            <a:schemeClr val="accent1"/>
+          </a:lnRef>
+          <a:fillRef idx="0">
+            <a:schemeClr val="accent1"/>
+          </a:fillRef>
+          <a:effectRef idx="1">
+            <a:schemeClr val="accent1"/>
+          </a:effectRef>
+          <a:fontRef idx="minor">
+            <a:schemeClr val="tx1"/>
+          </a:fontRef>
+        </p:style>
+      </p:cxnSp>
+      <p:sp>
+        <p:nvSpPr>
+          <p:cNvPr id="6" name="Pikslide"/>
           <p:cNvSpPr/>
           <p:nvPr/>
         </p:nvSpPr>
         <p:spPr>
           <a:xfrm>
-            <a:off x="5623560" y="137160"/>
-            <a:ext cx="731520" cy="502920"/>
+            <a:off x="3794760" y="594360"/>
+            <a:ext cx="1097279" cy="502920"/>
           </a:xfrm>
-          <a:prstGeom prst="foldedCorner">
-            <a:avLst/>
+          <a:prstGeom prst="roundRect">
+            <a:avLst>
+              <a:gd name="adj" fmla="val 18181"/>
+            </a:avLst>
           </a:prstGeom>
-          <a:noFill/>
+          <a:solidFill>
+            <a:schemeClr val="accent1"/>
+          </a:solidFill>
           <a:ln w="13716">
             <a:solidFill>
               <a:srgbClr val="000000"/>
@@ -3389,33 +3344,38 @@
               </a:lnSpc>
             </a:pPr>
             <a:r>
-              <a:rPr b="0" i="0" sz="1050">
+              <a:rPr b="1" i="0" sz="1050">
                 <a:solidFill>
-                  <a:srgbClr val="000000"/>
+                  <a:schemeClr val="bg1"/>
                 </a:solidFill>
                 <a:latin typeface="+mn-lt"/>
                 <a:ea typeface="+mn-ea"/>
               </a:rPr>
-              <a:t>.png</a:t>
-            </a:r>
-          </a:p>
-        </p:txBody>
-      </p:sp>
-      <p:sp>
-        <p:nvSpPr>
-          <p:cNvPr id="8" name="Pptx"/>
+              <a:t>pikslide</a:t>
+            </a:r>
+          </a:p>
+        </p:txBody>
+      </p:sp>
+      <p:sp>
+        <p:nvSpPr>
+          <p:cNvPr id="7" name="Png"/>
           <p:cNvSpPr/>
           <p:nvPr/>
         </p:nvSpPr>
         <p:spPr>
           <a:xfrm>
-            <a:off x="5623560" y="1051560"/>
+            <a:off x="5623560" y="137160"/>
             <a:ext cx="731520" cy="502920"/>
           </a:xfrm>
-          <a:prstGeom prst="foldedCorner">
+          <a:prstGeom prst="flowChartDocument">
             <a:avLst/>
           </a:prstGeom>
-          <a:noFill/>
+          <a:solidFill>
+            <a:schemeClr val="accent2">
+              <a:lumMod val="40000"/>
+              <a:lumOff val="60000"/>
+            </a:schemeClr>
+          </a:solidFill>
           <a:ln w="13716">
             <a:solidFill>
               <a:srgbClr val="000000"/>
@@ -3447,7 +3407,70 @@
               </a:lnSpc>
             </a:pPr>
             <a:r>
-              <a:rPr b="0" i="0" sz="1050">
+              <a:rPr b="1" i="0" sz="1050">
+                <a:solidFill>
+                  <a:srgbClr val="000000"/>
+                </a:solidFill>
+                <a:latin typeface="+mn-lt"/>
+                <a:ea typeface="+mn-ea"/>
+              </a:rPr>
+              <a:t>.png</a:t>
+            </a:r>
+          </a:p>
+        </p:txBody>
+      </p:sp>
+      <p:sp>
+        <p:nvSpPr>
+          <p:cNvPr id="8" name="Pptx"/>
+          <p:cNvSpPr/>
+          <p:nvPr/>
+        </p:nvSpPr>
+        <p:spPr>
+          <a:xfrm>
+            <a:off x="5623560" y="1051560"/>
+            <a:ext cx="731520" cy="502920"/>
+          </a:xfrm>
+          <a:prstGeom prst="flowChartDocument">
+            <a:avLst/>
+          </a:prstGeom>
+          <a:solidFill>
+            <a:schemeClr val="accent2">
+              <a:lumMod val="40000"/>
+              <a:lumOff val="60000"/>
+            </a:schemeClr>
+          </a:solidFill>
+          <a:ln w="13716">
+            <a:solidFill>
+              <a:srgbClr val="000000"/>
+            </a:solidFill>
+          </a:ln>
+          <a:effectLst/>
+        </p:spPr>
+        <p:style>
+          <a:lnRef idx="1">
+            <a:schemeClr val="accent1"/>
+          </a:lnRef>
+          <a:fillRef idx="3">
+            <a:schemeClr val="accent1"/>
+          </a:fillRef>
+          <a:effectRef idx="2">
+            <a:schemeClr val="accent1"/>
+          </a:effectRef>
+          <a:fontRef idx="minor">
+            <a:schemeClr val="lt1"/>
+          </a:fontRef>
+        </p:style>
+        <p:txBody>
+          <a:bodyPr rtlCol="0" anchor="ctr" wrap="square"/>
+          <a:lstStyle/>
+          <a:p>
+            <a:pPr algn="ctr">
+              <a:lnSpc>
+                <a:spcPct val="100000"/>
+              </a:lnSpc>
+            </a:pPr>
+            <a:r>
+              <a:rPr b="1" i="0" sz="1050">
                 <a:solidFill>
                   <a:srgbClr val="000000"/>
                 </a:solidFill>
@@ -3494,7 +3517,7 @@
             </a:pathLst>
           </a:custGeom>
           <a:noFill/>
-          <a:ln w="13716">
+          <a:ln w="27432">
             <a:solidFill>
               <a:srgbClr val="000000"/>
             </a:solidFill>
@@ -3616,7 +3639,7 @@
             </a:pathLst>
           </a:custGeom>
           <a:noFill/>
-          <a:ln w="13716">
+          <a:ln w="27432">
             <a:solidFill>
               <a:srgbClr val="000000"/>
             </a:solidFill>
@@ -3727,6 +3750,7 @@
             <a:solidFill>
               <a:srgbClr val="000000"/>
             </a:solidFill>
+            <a:prstDash val="dash"/>
             <a:headEnd type="none"/>
             <a:tailEnd type="triangle"/>
           </a:ln>
@@ -3875,8 +3899,8 @@
         </p:nvCxnSpPr>
         <p:spPr>
           <a:xfrm flipV="1">
-            <a:off x="2971800" y="1097280"/>
-            <a:ext cx="0" cy="1005840"/>
+            <a:off x="2971800" y="1063752"/>
+            <a:ext cx="0" cy="1039368"/>
           </a:xfrm>
           <a:prstGeom prst="line">
             <a:avLst/>
@@ -3913,8 +3937,8 @@
         </p:nvSpPr>
         <p:spPr>
           <a:xfrm>
-            <a:off x="3063240" y="1520189"/>
-            <a:ext cx="274319" cy="160020"/>
+            <a:off x="3063240" y="1503426"/>
+            <a:ext cx="1034429" cy="160020"/>
           </a:xfrm>
           <a:prstGeom prst="rect">
             <a:avLst/>
@@ -3940,7 +3964,7 @@
                 <a:latin typeface="+mn-lt"/>
                 <a:ea typeface="+mn-ea"/>
               </a:rPr>
-              <a:t>edit</a:t>
+              <a:t>edit in a text editor</a:t>
             </a:r>
           </a:p>
         </p:txBody>
@@ -3953,8 +3977,8 @@
         </p:nvCxnSpPr>
         <p:spPr>
           <a:xfrm flipV="1">
-            <a:off x="5989320" y="1554480"/>
-            <a:ext cx="0" cy="548640"/>
+            <a:off x="5989320" y="1520952"/>
+            <a:ext cx="0" cy="582168"/>
           </a:xfrm>
           <a:prstGeom prst="line">
             <a:avLst/>
@@ -3991,7 +4015,7 @@
         </p:nvSpPr>
         <p:spPr>
           <a:xfrm>
-            <a:off x="4901574" y="1748789"/>
+            <a:off x="4901574" y="1732026"/>
             <a:ext cx="996305" cy="160019"/>
           </a:xfrm>
           <a:prstGeom prst="rect">

</xml_diff>